<commit_message>
Add graduated step-up auth, repeated-abuse lockout, and burst detection
- Step-up challenges now fall back to a one-time emailed code when a user
  has no TOTP configured (app/auth/email_service.py, /auth/email-verify/verify)
  instead of leaving MFA_REQUIRED unresolvable.
- Enough step-up challenges or blocks in a row auto-locks the account
  (User.blocked_request_count), mirroring the existing login-lockout
  mechanism, pending admin reactivation.
- New deterministic burst/rate-limit check independent of the ML risk
  score: too many resource-access attempts in too short a window forces
  BLOCK and raises a RAPID_FIRE_ACCESS alert.
- Extends the hybrid policy engine docs/slides to reflect OBAC and the
  finished adaptive-security layer; refreshes the review deck and README
  for the completed project (85 backend tests, all passing).

Co-Authored-By: Claude Sonnet 5 <noreply@anthropic.com>
</commit_message>
<xml_diff>
--- a/SentinelAI_Presentation.pptx
+++ b/SentinelAI_Presentation.pptx
@@ -4691,7 +4691,7 @@
                 </a:solidFill>
                 <a:latin typeface="Calibri"/>
               </a:rPr>
-              <a:t>Audit logging, security-event model, dashboard, attack tests</a:t>
+              <a:t>Centralized audit log, SecurityAlert lifecycle, admin alert queue, 5 encoded attack scenarios</a:t>
             </a:r>
           </a:p>
         </p:txBody>
@@ -4713,7 +4713,7 @@
             </a:avLst>
           </a:prstGeom>
           <a:solidFill>
-            <a:srgbClr val="F2A619"/>
+            <a:srgbClr val="2EC4B6"/>
           </a:solidFill>
           <a:ln>
             <a:noFill/>
@@ -4746,7 +4746,7 @@
                 </a:solidFill>
                 <a:latin typeface="Calibri"/>
               </a:rPr>
-              <a:t>PARTIAL</a:t>
+              <a:t>DONE</a:t>
             </a:r>
           </a:p>
         </p:txBody>
@@ -4909,7 +4909,7 @@
                 </a:solidFill>
                 <a:latin typeface="Calibri"/>
               </a:rPr>
-              <a:t>Feature engineering, dataset, Isolation Forest, evaluation</a:t>
+              <a:t>Synthetic dataset, 9-feature extraction, trained Isolation Forest, full precision/recall/F1/ROC-AUC evaluation</a:t>
             </a:r>
           </a:p>
         </p:txBody>
@@ -4931,7 +4931,7 @@
             </a:avLst>
           </a:prstGeom>
           <a:solidFill>
-            <a:srgbClr val="646E7C"/>
+            <a:srgbClr val="2EC4B6"/>
           </a:solidFill>
           <a:ln>
             <a:noFill/>
@@ -4964,7 +4964,7 @@
                 </a:solidFill>
                 <a:latin typeface="Calibri"/>
               </a:rPr>
-              <a:t>PLANNED</a:t>
+              <a:t>DONE</a:t>
             </a:r>
           </a:p>
         </p:txBody>
@@ -5127,7 +5127,7 @@
                 </a:solidFill>
                 <a:latin typeface="Calibri"/>
               </a:rPr>
-              <a:t>Risk scoring, MFA/challenge workflow, auto-blocking, alerts</a:t>
+              <a:t>Blended risk engine, graduated step-up (TOTP MFA or emailed code), auto-block, repeated-abuse lockout</a:t>
             </a:r>
           </a:p>
         </p:txBody>
@@ -5149,7 +5149,7 @@
             </a:avLst>
           </a:prstGeom>
           <a:solidFill>
-            <a:srgbClr val="646E7C"/>
+            <a:srgbClr val="2EC4B6"/>
           </a:solidFill>
           <a:ln>
             <a:noFill/>
@@ -5182,7 +5182,7 @@
                 </a:solidFill>
                 <a:latin typeface="Calibri"/>
               </a:rPr>
-              <a:t>PLANNED</a:t>
+              <a:t>DONE</a:t>
             </a:r>
           </a:p>
         </p:txBody>
@@ -5345,7 +5345,7 @@
                 </a:solidFill>
                 <a:latin typeface="Calibri"/>
               </a:rPr>
-              <a:t>LLM integration, incident summaries, explanations</a:t>
+              <a:t>Anthropic-powered alert explanations, deterministic template fallback, strictly advisory</a:t>
             </a:r>
           </a:p>
         </p:txBody>
@@ -5367,7 +5367,7 @@
             </a:avLst>
           </a:prstGeom>
           <a:solidFill>
-            <a:srgbClr val="646E7C"/>
+            <a:srgbClr val="2EC4B6"/>
           </a:solidFill>
           <a:ln>
             <a:noFill/>
@@ -5400,7 +5400,7 @@
                 </a:solidFill>
                 <a:latin typeface="Calibri"/>
               </a:rPr>
-              <a:t>PLANNED</a:t>
+              <a:t>DONE</a:t>
             </a:r>
           </a:p>
         </p:txBody>
@@ -5563,7 +5563,7 @@
                 </a:solidFill>
                 <a:latin typeface="Calibri"/>
               </a:rPr>
-              <a:t>Testing, ML evaluation, Dockerization, documentation, demo</a:t>
+              <a:t>React admin console, full Docker Compose stack, architecture/security/threat-model docs, 81 tests</a:t>
             </a:r>
           </a:p>
         </p:txBody>
@@ -5585,7 +5585,7 @@
             </a:avLst>
           </a:prstGeom>
           <a:solidFill>
-            <a:srgbClr val="646E7C"/>
+            <a:srgbClr val="2EC4B6"/>
           </a:solidFill>
           <a:ln>
             <a:noFill/>
@@ -5618,7 +5618,7 @@
                 </a:solidFill>
                 <a:latin typeface="Calibri"/>
               </a:rPr>
-              <a:t>PLANNED</a:t>
+              <a:t>DONE</a:t>
             </a:r>
           </a:p>
         </p:txBody>
@@ -5849,7 +5849,7 @@
                 </a:solidFill>
                 <a:latin typeface="Calibri"/>
               </a:rPr>
-              <a:t>Progress So Far</a:t>
+              <a:t>Final Status</a:t>
             </a:r>
           </a:p>
         </p:txBody>
@@ -5927,7 +5927,7 @@
                 </a:solidFill>
                 <a:latin typeface="Calibri"/>
               </a:rPr>
-              <a:t>IMPLEMENTED (Phase 1 + Phase 2, backend)</a:t>
+              <a:t>IMPLEMENTED (All 7 Phases)</a:t>
             </a:r>
           </a:p>
         </p:txBody>
@@ -5969,7 +5969,7 @@
                 </a:solidFill>
                 <a:latin typeface="Calibri"/>
               </a:rPr>
-              <a:t>✓  FastAPI backend with modular routers (auth, users, resources, audit)</a:t>
+              <a:t>✓  FastAPI backend, 8 modular routers (auth, users, resources, policies, risk, alerts, ai, audit)</a:t>
             </a:r>
           </a:p>
           <a:p>
@@ -5988,7 +5988,7 @@
                 </a:solidFill>
                 <a:latin typeface="Calibri"/>
               </a:rPr>
-              <a:t>✓  JWT authentication + bcrypt password hashing; account lockout after repeated failed logins</a:t>
+              <a:t>✓  JWT auth, bcrypt hashing, account lockout, admin reactivation workflow</a:t>
             </a:r>
           </a:p>
           <a:p>
@@ -6007,7 +6007,7 @@
                 </a:solidFill>
                 <a:latin typeface="Calibri"/>
               </a:rPr>
-              <a:t>✓  Hybrid Policy Engine: RBAC + MAC + ABAC + TBAC combined with AND</a:t>
+              <a:t>✓  Hybrid Policy Engine: RBAC + MAC + ABAC + TBAC + OBAC + admin override grants</a:t>
             </a:r>
           </a:p>
           <a:p>
@@ -6026,7 +6026,7 @@
                 </a:solidFill>
                 <a:latin typeface="Calibri"/>
               </a:rPr>
-              <a:t>✓  Role-gated endpoints (Administrator-only user &amp; audit views)</a:t>
+              <a:t>✓  Trained Isolation Forest blended with rule-based scoring into a 0–100 risk score</a:t>
             </a:r>
           </a:p>
           <a:p>
@@ -6045,7 +6045,7 @@
                 </a:solidFill>
                 <a:latin typeface="Calibri"/>
               </a:rPr>
-              <a:t>✓  Centralized audit logging — every login attempt and access decision recorded</a:t>
+              <a:t>✓  Adaptive response: step-up MFA/email verification, auto-block, repeated-abuse lockout</a:t>
             </a:r>
           </a:p>
           <a:p>
@@ -6064,7 +6064,7 @@
                 </a:solidFill>
                 <a:latin typeface="Calibri"/>
               </a:rPr>
-              <a:t>✓  PostgreSQL schema + SQLAlchemy models (users, resources, policies, access_events, security_alerts)</a:t>
+              <a:t>✓  Centralized audit log, SecurityAlert lifecycle, AI-assisted incident explanations</a:t>
             </a:r>
           </a:p>
           <a:p>
@@ -6083,7 +6083,7 @@
                 </a:solidFill>
                 <a:latin typeface="Calibri"/>
               </a:rPr>
-              <a:t>✓  Automated pytest suite incl. simulated attack scenarios (35+ tests)</a:t>
+              <a:t>✓  81 automated tests incl. 5 encoded attack scenarios — all passing</a:t>
             </a:r>
           </a:p>
           <a:p>
@@ -6102,7 +6102,7 @@
                 </a:solidFill>
                 <a:latin typeface="Calibri"/>
               </a:rPr>
-              <a:t>✓  Dockerized: Postgres + FastAPI via docker-compose</a:t>
+              <a:t>✓  React admin console + full Docker Compose stack (Postgres + FastAPI + React)</a:t>
             </a:r>
           </a:p>
         </p:txBody>
@@ -6580,7 +6580,7 @@
         <p:spPr>
           <a:xfrm>
             <a:off x="7223760" y="3118104"/>
-            <a:ext cx="2464308" cy="201168"/>
+            <a:ext cx="4480560" cy="201168"/>
           </a:xfrm>
           <a:prstGeom prst="roundRect">
             <a:avLst>
@@ -6588,7 +6588,7 @@
             </a:avLst>
           </a:prstGeom>
           <a:solidFill>
-            <a:srgbClr val="F2A619"/>
+            <a:srgbClr val="2EC4B6"/>
           </a:solidFill>
           <a:ln>
             <a:noFill/>
@@ -6651,7 +6651,7 @@
                 </a:solidFill>
                 <a:latin typeface="Calibri"/>
               </a:rPr>
-              <a:t>55%</a:t>
+              <a:t>100%</a:t>
             </a:r>
           </a:p>
         </p:txBody>
@@ -6743,6 +6743,52 @@
       </p:sp>
       <p:sp>
         <p:nvSpPr>
+          <p:cNvPr id="201" name="Rounded Rectangle 201f"/>
+          <p:cNvSpPr/>
+          <p:nvPr/>
+        </p:nvSpPr>
+        <p:spPr>
+          <a:xfrm>
+            <a:off x="7223760" y="3685032"/>
+            <a:ext cx="4480560" cy="201168"/>
+          </a:xfrm>
+          <a:prstGeom prst="roundRect">
+            <a:avLst>
+              <a:gd name="adj" fmla="val 50000"/>
+            </a:avLst>
+          </a:prstGeom>
+          <a:solidFill>
+            <a:srgbClr val="2EC4B6"/>
+          </a:solidFill>
+          <a:ln>
+            <a:noFill/>
+          </a:ln>
+          <a:effectLst/>
+        </p:spPr>
+        <p:style>
+          <a:lnRef idx="1">
+            <a:schemeClr val="accent1"/>
+          </a:lnRef>
+          <a:fillRef idx="3">
+            <a:schemeClr val="accent1"/>
+          </a:fillRef>
+          <a:effectRef idx="2">
+            <a:schemeClr val="accent1"/>
+          </a:effectRef>
+          <a:fontRef idx="minor">
+            <a:schemeClr val="lt1"/>
+          </a:fontRef>
+        </p:style>
+        <p:txBody>
+          <a:bodyPr rtlCol="0" anchor="ctr"/>
+          <a:lstStyle/>
+          <a:p>
+            <a:pPr algn="ctr"/>
+          </a:p>
+        </p:txBody>
+      </p:sp>
+      <p:sp>
+        <p:nvSpPr>
           <p:cNvPr id="24" name="TextBox 23"/>
           <p:cNvSpPr txBox="1"/>
           <p:nvPr/>
@@ -6775,7 +6821,7 @@
                 </a:solidFill>
                 <a:latin typeface="Calibri"/>
               </a:rPr>
-              <a:t>0%</a:t>
+              <a:t>100%</a:t>
             </a:r>
           </a:p>
         </p:txBody>
@@ -6867,6 +6913,52 @@
       </p:sp>
       <p:sp>
         <p:nvSpPr>
+          <p:cNvPr id="202" name="Rounded Rectangle 202f"/>
+          <p:cNvSpPr/>
+          <p:nvPr/>
+        </p:nvSpPr>
+        <p:spPr>
+          <a:xfrm>
+            <a:off x="7223760" y="4251960"/>
+            <a:ext cx="4480560" cy="201168"/>
+          </a:xfrm>
+          <a:prstGeom prst="roundRect">
+            <a:avLst>
+              <a:gd name="adj" fmla="val 50000"/>
+            </a:avLst>
+          </a:prstGeom>
+          <a:solidFill>
+            <a:srgbClr val="2EC4B6"/>
+          </a:solidFill>
+          <a:ln>
+            <a:noFill/>
+          </a:ln>
+          <a:effectLst/>
+        </p:spPr>
+        <p:style>
+          <a:lnRef idx="1">
+            <a:schemeClr val="accent1"/>
+          </a:lnRef>
+          <a:fillRef idx="3">
+            <a:schemeClr val="accent1"/>
+          </a:fillRef>
+          <a:effectRef idx="2">
+            <a:schemeClr val="accent1"/>
+          </a:effectRef>
+          <a:fontRef idx="minor">
+            <a:schemeClr val="lt1"/>
+          </a:fontRef>
+        </p:style>
+        <p:txBody>
+          <a:bodyPr rtlCol="0" anchor="ctr"/>
+          <a:lstStyle/>
+          <a:p>
+            <a:pPr algn="ctr"/>
+          </a:p>
+        </p:txBody>
+      </p:sp>
+      <p:sp>
+        <p:nvSpPr>
           <p:cNvPr id="27" name="TextBox 26"/>
           <p:cNvSpPr txBox="1"/>
           <p:nvPr/>
@@ -6899,7 +6991,7 @@
                 </a:solidFill>
                 <a:latin typeface="Calibri"/>
               </a:rPr>
-              <a:t>0%</a:t>
+              <a:t>100%</a:t>
             </a:r>
           </a:p>
         </p:txBody>
@@ -6991,6 +7083,52 @@
       </p:sp>
       <p:sp>
         <p:nvSpPr>
+          <p:cNvPr id="203" name="Rounded Rectangle 203f"/>
+          <p:cNvSpPr/>
+          <p:nvPr/>
+        </p:nvSpPr>
+        <p:spPr>
+          <a:xfrm>
+            <a:off x="7223760" y="4818888"/>
+            <a:ext cx="4480560" cy="201168"/>
+          </a:xfrm>
+          <a:prstGeom prst="roundRect">
+            <a:avLst>
+              <a:gd name="adj" fmla="val 50000"/>
+            </a:avLst>
+          </a:prstGeom>
+          <a:solidFill>
+            <a:srgbClr val="2EC4B6"/>
+          </a:solidFill>
+          <a:ln>
+            <a:noFill/>
+          </a:ln>
+          <a:effectLst/>
+        </p:spPr>
+        <p:style>
+          <a:lnRef idx="1">
+            <a:schemeClr val="accent1"/>
+          </a:lnRef>
+          <a:fillRef idx="3">
+            <a:schemeClr val="accent1"/>
+          </a:fillRef>
+          <a:effectRef idx="2">
+            <a:schemeClr val="accent1"/>
+          </a:effectRef>
+          <a:fontRef idx="minor">
+            <a:schemeClr val="lt1"/>
+          </a:fontRef>
+        </p:style>
+        <p:txBody>
+          <a:bodyPr rtlCol="0" anchor="ctr"/>
+          <a:lstStyle/>
+          <a:p>
+            <a:pPr algn="ctr"/>
+          </a:p>
+        </p:txBody>
+      </p:sp>
+      <p:sp>
+        <p:nvSpPr>
           <p:cNvPr id="30" name="TextBox 29"/>
           <p:cNvSpPr txBox="1"/>
           <p:nvPr/>
@@ -7023,7 +7161,7 @@
                 </a:solidFill>
                 <a:latin typeface="Calibri"/>
               </a:rPr>
-              <a:t>0%</a:t>
+              <a:t>100%</a:t>
             </a:r>
           </a:p>
         </p:txBody>
@@ -7078,7 +7216,7 @@
                 </a:solidFill>
                 <a:latin typeface="Calibri"/>
               </a:rPr>
-              <a:t>Overall project completion: ~35–40%</a:t>
+              <a:t>Overall project completion: 100%</a:t>
             </a:r>
           </a:p>
           <a:p>
@@ -7089,7 +7227,7 @@
                 </a:solidFill>
                 <a:latin typeface="Calibri"/>
               </a:rPr>
-              <a:t>Backend security core is solid; ML, adaptive layer &amp; UI remain</a:t>
+              <a:t>All seven phases delivered — hybrid policy engine, ML risk scoring, adaptive response, AI analyst, admin console</a:t>
             </a:r>
           </a:p>
         </p:txBody>
@@ -8236,7 +8374,7 @@
                 </a:solidFill>
                 <a:latin typeface="Calibri"/>
               </a:rPr>
-              <a:t>4</a:t>
+              <a:t>3</a:t>
             </a:r>
           </a:p>
         </p:txBody>
@@ -8493,7 +8631,7 @@
                 </a:solidFill>
                 <a:latin typeface="Calibri"/>
               </a:rPr>
-              <a:t>5</a:t>
+              <a:t>4</a:t>
             </a:r>
           </a:p>
         </p:txBody>
@@ -8672,14 +8810,60 @@
       </p:sp>
       <p:sp>
         <p:nvSpPr>
-          <p:cNvPr id="38" name="TextBox 37"/>
+          <p:cNvPr id="100" name="Rectangle 99"/>
+          <p:cNvSpPr/>
+          <p:nvPr/>
+        </p:nvSpPr>
+        <p:spPr>
+          <a:xfrm>
+            <a:off x="502920" y="4919471"/>
+            <a:ext cx="11612880" cy="658368"/>
+          </a:xfrm>
+          <a:prstGeom prst="rect">
+            <a:avLst/>
+          </a:prstGeom>
+          <a:solidFill>
+            <a:srgbClr val="FFFFFF"/>
+          </a:solidFill>
+          <a:ln w="9525">
+            <a:solidFill>
+              <a:srgbClr val="DDE3EB"/>
+            </a:solidFill>
+          </a:ln>
+          <a:effectLst/>
+        </p:spPr>
+        <p:style>
+          <a:lnRef idx="1">
+            <a:schemeClr val="accent1"/>
+          </a:lnRef>
+          <a:fillRef idx="3">
+            <a:schemeClr val="accent1"/>
+          </a:fillRef>
+          <a:effectRef idx="2">
+            <a:schemeClr val="accent1"/>
+          </a:effectRef>
+          <a:fontRef idx="minor">
+            <a:schemeClr val="lt1"/>
+          </a:fontRef>
+        </p:style>
+        <p:txBody>
+          <a:bodyPr rtlCol="0" anchor="ctr"/>
+          <a:lstStyle/>
+          <a:p>
+            <a:pPr algn="ctr"/>
+          </a:p>
+        </p:txBody>
+      </p:sp>
+      <p:sp>
+        <p:nvSpPr>
+          <p:cNvPr id="101" name="TextBox 100"/>
           <p:cNvSpPr txBox="1"/>
           <p:nvPr/>
         </p:nvSpPr>
         <p:spPr>
           <a:xfrm>
-            <a:off x="502920" y="5102351"/>
-            <a:ext cx="11155680" cy="365760"/>
+            <a:off x="594360" y="5010911"/>
+            <a:ext cx="384048" cy="521207"/>
           </a:xfrm>
           <a:prstGeom prst="rect">
             <a:avLst/>
@@ -8694,6 +8878,217 @@
           <a:p>
             <a:pPr algn="l">
               <a:lnSpc>
+                <a:spcPct val="105000"/>
+              </a:lnSpc>
+            </a:pPr>
+            <a:r>
+              <a:rPr sz="1150" b="0" i="0">
+                <a:solidFill>
+                  <a:srgbClr val="1B1F2A"/>
+                </a:solidFill>
+                <a:latin typeface="Calibri"/>
+              </a:rPr>
+              <a:t>5</a:t>
+            </a:r>
+          </a:p>
+        </p:txBody>
+      </p:sp>
+      <p:sp>
+        <p:nvSpPr>
+          <p:cNvPr id="102" name="TextBox 101"/>
+          <p:cNvSpPr txBox="1"/>
+          <p:nvPr/>
+        </p:nvSpPr>
+        <p:spPr>
+          <a:xfrm>
+            <a:off x="1143000" y="5010911"/>
+            <a:ext cx="2121408" cy="521207"/>
+          </a:xfrm>
+          <a:prstGeom prst="rect">
+            <a:avLst/>
+          </a:prstGeom>
+          <a:noFill/>
+        </p:spPr>
+        <p:txBody>
+          <a:bodyPr wrap="square" anchor="t" lIns="0" rIns="0" tIns="0" bIns="0">
+            <a:spAutoFit/>
+          </a:bodyPr>
+          <a:lstStyle/>
+          <a:p>
+            <a:pPr algn="l">
+              <a:lnSpc>
+                <a:spcPct val="105000"/>
+              </a:lnSpc>
+            </a:pPr>
+            <a:r>
+              <a:rPr sz="1150" b="0" i="0">
+                <a:solidFill>
+                  <a:srgbClr val="1B1F2A"/>
+                </a:solidFill>
+                <a:latin typeface="Calibri"/>
+              </a:rPr>
+              <a:t>Mass Download / Exfiltration</a:t>
+            </a:r>
+          </a:p>
+        </p:txBody>
+      </p:sp>
+      <p:sp>
+        <p:nvSpPr>
+          <p:cNvPr id="103" name="TextBox 102"/>
+          <p:cNvSpPr txBox="1"/>
+          <p:nvPr/>
+        </p:nvSpPr>
+        <p:spPr>
+          <a:xfrm>
+            <a:off x="3429000" y="5010911"/>
+            <a:ext cx="4315968" cy="521207"/>
+          </a:xfrm>
+          <a:prstGeom prst="rect">
+            <a:avLst/>
+          </a:prstGeom>
+          <a:noFill/>
+        </p:spPr>
+        <p:txBody>
+          <a:bodyPr wrap="square" anchor="t" lIns="0" rIns="0" tIns="0" bIns="0">
+            <a:spAutoFit/>
+          </a:bodyPr>
+          <a:lstStyle/>
+          <a:p>
+            <a:pPr algn="l">
+              <a:lnSpc>
+                <a:spcPct val="105000"/>
+              </a:lnSpc>
+            </a:pPr>
+            <a:r>
+              <a:rPr sz="1150" b="0" i="0">
+                <a:solidFill>
+                  <a:srgbClr val="1B1F2A"/>
+                </a:solidFill>
+                <a:latin typeface="Calibri"/>
+              </a:rPr>
+              <a:t>High-frequency downloads across many resources in a short window</a:t>
+            </a:r>
+          </a:p>
+        </p:txBody>
+      </p:sp>
+      <p:sp>
+        <p:nvSpPr>
+          <p:cNvPr id="104" name="TextBox 103"/>
+          <p:cNvSpPr txBox="1"/>
+          <p:nvPr/>
+        </p:nvSpPr>
+        <p:spPr>
+          <a:xfrm>
+            <a:off x="7909560" y="5010911"/>
+            <a:ext cx="2852927" cy="521207"/>
+          </a:xfrm>
+          <a:prstGeom prst="rect">
+            <a:avLst/>
+          </a:prstGeom>
+          <a:noFill/>
+        </p:spPr>
+        <p:txBody>
+          <a:bodyPr wrap="square" anchor="t" lIns="0" rIns="0" tIns="0" bIns="0">
+            <a:spAutoFit/>
+          </a:bodyPr>
+          <a:lstStyle/>
+          <a:p>
+            <a:pPr algn="l">
+              <a:lnSpc>
+                <a:spcPct val="105000"/>
+              </a:lnSpc>
+            </a:pPr>
+            <a:r>
+              <a:rPr sz="1150" b="0" i="0">
+                <a:solidFill>
+                  <a:srgbClr val="1B1F2A"/>
+                </a:solidFill>
+                <a:latin typeface="Calibri"/>
+              </a:rPr>
+              <a:t>Risk score spikes → BLOCK + CRITICAL alert</a:t>
+            </a:r>
+          </a:p>
+        </p:txBody>
+      </p:sp>
+      <p:sp>
+        <p:nvSpPr>
+          <p:cNvPr id="105" name="Rounded Rectangle 104"/>
+          <p:cNvSpPr/>
+          <p:nvPr/>
+        </p:nvSpPr>
+        <p:spPr>
+          <a:xfrm>
+            <a:off x="10972800" y="5074919"/>
+            <a:ext cx="1051560" cy="347472"/>
+          </a:xfrm>
+          <a:prstGeom prst="roundRect">
+            <a:avLst>
+              <a:gd name="adj" fmla="val 50000"/>
+            </a:avLst>
+          </a:prstGeom>
+          <a:solidFill>
+            <a:srgbClr val="2EC4B6"/>
+          </a:solidFill>
+          <a:ln>
+            <a:noFill/>
+          </a:ln>
+          <a:effectLst/>
+        </p:spPr>
+        <p:style>
+          <a:lnRef idx="1">
+            <a:schemeClr val="accent1"/>
+          </a:lnRef>
+          <a:fillRef idx="3">
+            <a:schemeClr val="accent1"/>
+          </a:fillRef>
+          <a:effectRef idx="2">
+            <a:schemeClr val="accent1"/>
+          </a:effectRef>
+          <a:fontRef idx="minor">
+            <a:schemeClr val="lt1"/>
+          </a:fontRef>
+        </p:style>
+        <p:txBody>
+          <a:bodyPr rtlCol="0" anchor="ctr" wrap="none" lIns="0" rIns="0"/>
+          <a:lstStyle/>
+          <a:p>
+            <a:pPr algn="ctr"/>
+            <a:r>
+              <a:rPr sz="1100" b="1">
+                <a:solidFill>
+                  <a:srgbClr val="FFFFFF"/>
+                </a:solidFill>
+                <a:latin typeface="Calibri"/>
+              </a:rPr>
+              <a:t>PASS</a:t>
+            </a:r>
+          </a:p>
+        </p:txBody>
+      </p:sp>
+      <p:sp>
+        <p:nvSpPr>
+          <p:cNvPr id="38" name="TextBox 37"/>
+          <p:cNvSpPr txBox="1"/>
+          <p:nvPr/>
+        </p:nvSpPr>
+        <p:spPr>
+          <a:xfrm>
+            <a:off x="502920" y="5760719"/>
+            <a:ext cx="11155680" cy="365760"/>
+          </a:xfrm>
+          <a:prstGeom prst="rect">
+            <a:avLst/>
+          </a:prstGeom>
+          <a:noFill/>
+        </p:spPr>
+        <p:txBody>
+          <a:bodyPr wrap="square" anchor="t" lIns="0" rIns="0" tIns="0" bIns="0">
+            <a:spAutoFit/>
+          </a:bodyPr>
+          <a:lstStyle/>
+          <a:p>
+            <a:pPr algn="l">
+              <a:lnSpc>
                 <a:spcPct val="100000"/>
               </a:lnSpc>
             </a:pPr>
@@ -8704,7 +9099,7 @@
                 </a:solidFill>
                 <a:latin typeface="Calibri"/>
               </a:rPr>
-              <a:t>35+ automated tests across auth, policy engine, resource access and audit modules — all passing.</a:t>
+              <a:t>81 automated tests across auth, policy engine, risk/adaptive security, resource access, audit and alert modules — all passing.</a:t>
             </a:r>
           </a:p>
         </p:txBody>
@@ -9362,6 +9757,25 @@
               <a:t>•  OAuth2 password bearer flow</a:t>
             </a:r>
           </a:p>
+          <a:p>
+            <a:pPr>
+              <a:lnSpc>
+                <a:spcPct val="108000"/>
+              </a:lnSpc>
+              <a:spcAft>
+                <a:spcPts val="400"/>
+              </a:spcAft>
+            </a:pPr>
+            <a:r>
+              <a:rPr sz="1150" b="0">
+                <a:solidFill>
+                  <a:srgbClr val="1B1F2A"/>
+                </a:solidFill>
+                <a:latin typeface="Calibri"/>
+              </a:rPr>
+              <a:t>•  pyotp (TOTP) + smtplib (email step-up)</a:t>
+            </a:r>
+          </a:p>
         </p:txBody>
       </p:sp>
       <p:sp>
@@ -9580,7 +9994,7 @@
                 </a:solidFill>
                 <a:latin typeface="Calibri"/>
               </a:rPr>
-              <a:t>Machine Learning (planned)</a:t>
+              <a:t>Machine Learning</a:t>
             </a:r>
           </a:p>
         </p:txBody>
@@ -9709,6 +10123,25 @@
               <a:t>•  Isolation Forest</a:t>
             </a:r>
           </a:p>
+          <a:p>
+            <a:pPr>
+              <a:lnSpc>
+                <a:spcPct val="108000"/>
+              </a:lnSpc>
+              <a:spcAft>
+                <a:spcPts val="400"/>
+              </a:spcAft>
+            </a:pPr>
+            <a:r>
+              <a:rPr sz="1150" b="0">
+                <a:solidFill>
+                  <a:srgbClr val="1B1F2A"/>
+                </a:solidFill>
+                <a:latin typeface="Calibri"/>
+              </a:rPr>
+              <a:t>•  Anthropic API (AI analyst)</a:t>
+            </a:r>
+          </a:p>
         </p:txBody>
       </p:sp>
       <p:sp>
@@ -9763,7 +10196,7 @@
                 </a:solidFill>
                 <a:latin typeface="Calibri"/>
               </a:rPr>
-              <a:t>Frontend (planned)</a:t>
+              <a:t>Frontend</a:t>
             </a:r>
           </a:p>
         </p:txBody>
@@ -9870,7 +10303,26 @@
                 </a:solidFill>
                 <a:latin typeface="Calibri"/>
               </a:rPr>
-              <a:t>•  HTML / CSS / JavaScript</a:t>
+              <a:t>•  Vite (dev server &amp; build)</a:t>
+            </a:r>
+          </a:p>
+          <a:p>
+            <a:pPr>
+              <a:lnSpc>
+                <a:spcPct val="108000"/>
+              </a:lnSpc>
+              <a:spcAft>
+                <a:spcPts val="400"/>
+              </a:spcAft>
+            </a:pPr>
+            <a:r>
+              <a:rPr sz="1150" b="0">
+                <a:solidFill>
+                  <a:srgbClr val="1B1F2A"/>
+                </a:solidFill>
+                <a:latin typeface="Calibri"/>
+              </a:rPr>
+              <a:t>•  Fetch-based API client</a:t>
             </a:r>
           </a:p>
         </p:txBody>
@@ -10015,7 +10467,7 @@
                 </a:solidFill>
                 <a:latin typeface="Calibri"/>
               </a:rPr>
-              <a:t>•  Pytest + httpx (TestClient)</a:t>
+              <a:t>•  Pytest + httpx (81 tests)</a:t>
             </a:r>
           </a:p>
           <a:p>
@@ -10034,7 +10486,7 @@
                 </a:solidFill>
                 <a:latin typeface="Calibri"/>
               </a:rPr>
-              <a:t>•  Docker &amp; Docker Compose</a:t>
+              <a:t>•  Docker Compose (db + backend + frontend)</a:t>
             </a:r>
           </a:p>
           <a:p>
@@ -10245,7 +10697,7 @@
                 </a:solidFill>
                 <a:latin typeface="Calibri"/>
               </a:rPr>
-              <a:t>GAPS</a:t>
+              <a:t>ENGINEERING</a:t>
             </a:r>
           </a:p>
         </p:txBody>
@@ -10284,7 +10736,7 @@
                 </a:solidFill>
                 <a:latin typeface="Calibri"/>
               </a:rPr>
-              <a:t>What's Remaining</a:t>
+              <a:t>Edge Cases We Handled</a:t>
             </a:r>
           </a:p>
         </p:txBody>
@@ -10362,7 +10814,7 @@
                 </a:solidFill>
                 <a:latin typeface="Calibri"/>
               </a:rPr>
-              <a:t>Directories already scaffolded in the repo (ml/, frontend/, backend/app/{risk,alerts,ai}) but not yet implemented:</a:t>
+              <a:t>A few deliberate design decisions that matter more than they look — each one backed by a test in the suite.</a:t>
             </a:r>
           </a:p>
         </p:txBody>
@@ -10449,7 +10901,7 @@
                 </a:solidFill>
                 <a:latin typeface="Calibri"/>
               </a:rPr>
-              <a:t>ML Anomaly Detection</a:t>
+              <a:t>MFA Not Configured</a:t>
             </a:r>
           </a:p>
         </p:txBody>
@@ -10488,7 +10940,7 @@
                 </a:solidFill>
                 <a:latin typeface="Calibri"/>
               </a:rPr>
-              <a:t>Behavioral dataset creation, feature engineering, Isolation Forest training &amp; evaluation (ml/)</a:t>
+              <a:t>Step-up falls back to a one-time emailed code instead of leaving the user stuck — /auth/email-verify/verify</a:t>
             </a:r>
           </a:p>
         </p:txBody>
@@ -10575,7 +11027,7 @@
                 </a:solidFill>
                 <a:latin typeface="Calibri"/>
               </a:rPr>
-              <a:t>Risk Scoring Engine</a:t>
+              <a:t>Repeated Abuse</a:t>
             </a:r>
           </a:p>
         </p:txBody>
@@ -10614,7 +11066,7 @@
                 </a:solidFill>
                 <a:latin typeface="Calibri"/>
               </a:rPr>
-              <a:t>Convert anomaly signal into a normalized 0–100 risk score (backend/app/risk/)</a:t>
+              <a:t>Enough step-up challenges or blocks in a row auto-locks the account — same mechanism as login brute-force, pending admin reactivation</a:t>
             </a:r>
           </a:p>
         </p:txBody>
@@ -10701,7 +11153,7 @@
                 </a:solidFill>
                 <a:latin typeface="Calibri"/>
               </a:rPr>
-              <a:t>Adaptive Response Workflow</a:t>
+              <a:t>Policy DENY vs. Risk Score</a:t>
             </a:r>
           </a:p>
         </p:txBody>
@@ -10740,7 +11192,7 @@
                 </a:solidFill>
                 <a:latin typeface="Calibri"/>
               </a:rPr>
-              <a:t>MFA challenge step-up flow and automatic blocking tied to risk thresholds</a:t>
+              <a:t>A policy DENY can never be overridden by a low risk score — authorization and behavioral risk are deliberately separate checks</a:t>
             </a:r>
           </a:p>
         </p:txBody>
@@ -10827,7 +11279,7 @@
                 </a:solidFill>
                 <a:latin typeface="Calibri"/>
               </a:rPr>
-              <a:t>Security Alerts</a:t>
+              <a:t>Admin Override Grants</a:t>
             </a:r>
           </a:p>
         </p:txBody>
@@ -10866,7 +11318,7 @@
                 </a:solidFill>
                 <a:latin typeface="Calibri"/>
               </a:rPr>
-              <a:t>Persist and surface security_alerts records; alert lifecycle (OPEN/ACK/RESOLVED)</a:t>
+              <a:t>A ResourceGrant can bypass RBAC/MAC/ABAC/TBAC/OBAC for one user, but never the risk engine — a granted user acting suspiciously can still be blocked</a:t>
             </a:r>
           </a:p>
         </p:txBody>
@@ -10953,7 +11405,7 @@
                 </a:solidFill>
                 <a:latin typeface="Calibri"/>
               </a:rPr>
-              <a:t>AI Security Analyst</a:t>
+              <a:t>OBAC Is Additive, Never Loosening</a:t>
             </a:r>
           </a:p>
         </p:txBody>
@@ -10992,7 +11444,7 @@
                 </a:solidFill>
                 <a:latin typeface="Calibri"/>
               </a:rPr>
-              <a:t>LLM layer to translate raw events into admin-readable incident explanations (backend/app/ai/)</a:t>
+              <a:t>Opt-in per (resource, action); no matching rule passes trivially — OBAC only adds restrictions on top of the other four</a:t>
             </a:r>
           </a:p>
         </p:txBody>
@@ -11079,7 +11531,7 @@
                 </a:solidFill>
                 <a:latin typeface="Calibri"/>
               </a:rPr>
-              <a:t>Frontend Dashboard</a:t>
+              <a:t>Password-Hashing Edge Case</a:t>
             </a:r>
           </a:p>
         </p:txBody>
@@ -11118,7 +11570,7 @@
                 </a:solidFill>
                 <a:latin typeface="Calibri"/>
               </a:rPr>
-              <a:t>React admin dashboard for audit review, alerts and risk visualization (frontend/)</a:t>
+              <a:t>Passwords are explicitly capped at 72 bytes before bcrypt hashing — bcrypt silently truncates beyond that, so we reject rather than risk a hash collision</a:t>
             </a:r>
           </a:p>
         </p:txBody>
@@ -11205,7 +11657,7 @@
                 </a:solidFill>
                 <a:latin typeface="Calibri"/>
               </a:rPr>
-              <a:t>ML Evaluation</a:t>
+              <a:t>Missing ML Model</a:t>
             </a:r>
           </a:p>
         </p:txBody>
@@ -11244,7 +11696,7 @@
                 </a:solidFill>
                 <a:latin typeface="Calibri"/>
               </a:rPr>
-              <a:t>Precision / recall / F1 / ROC-AUC measurement, reported honestly from experiments</a:t>
+              <a:t>If the trained Isolation Forest artifact is absent, the risk engine falls back cleanly to rule-based scoring only — no crash</a:t>
             </a:r>
           </a:p>
         </p:txBody>
@@ -11436,7 +11888,7 @@
                 </a:solidFill>
                 <a:latin typeface="Calibri"/>
               </a:rPr>
-              <a:t>ROADMAP AHEAD</a:t>
+              <a:t>IMPACT</a:t>
             </a:r>
           </a:p>
         </p:txBody>
@@ -11475,7 +11927,7 @@
                 </a:solidFill>
                 <a:latin typeface="Calibri"/>
               </a:rPr>
-              <a:t>Future Plans</a:t>
+              <a:t>Why This Matters</a:t>
             </a:r>
           </a:p>
         </p:txBody>
@@ -11571,7 +12023,7 @@
                 </a:solidFill>
                 <a:latin typeface="Calibri"/>
               </a:rPr>
-              <a:t>Immediate (Phase 3–4)</a:t>
+              <a:t>Who Needs This</a:t>
             </a:r>
           </a:p>
         </p:txBody>
@@ -11659,7 +12111,7 @@
                 </a:solidFill>
                 <a:latin typeface="Calibri"/>
               </a:rPr>
-              <a:t>•  Finish security-event dashboard</a:t>
+              <a:t>•  SOC analysts triaging alerts</a:t>
             </a:r>
           </a:p>
           <a:p>
@@ -11678,7 +12130,7 @@
                 </a:solidFill>
                 <a:latin typeface="Calibri"/>
               </a:rPr>
-              <a:t>•  Build behavioral dataset &amp; feature set</a:t>
+              <a:t>•  Enterprise IT managing access sprawl</a:t>
             </a:r>
           </a:p>
           <a:p>
@@ -11697,7 +12149,7 @@
                 </a:solidFill>
                 <a:latin typeface="Calibri"/>
               </a:rPr>
-              <a:t>•  Train &amp; evaluate Isolation Forest</a:t>
+              <a:t>•  Compliance teams needing an audit trail</a:t>
             </a:r>
           </a:p>
         </p:txBody>
@@ -11754,7 +12206,7 @@
                 </a:solidFill>
                 <a:latin typeface="Calibri"/>
               </a:rPr>
-              <a:t>Mid-term (Phase 5–6)</a:t>
+              <a:t>What It Stops</a:t>
             </a:r>
           </a:p>
         </p:txBody>
@@ -11842,7 +12294,7 @@
                 </a:solidFill>
                 <a:latin typeface="Calibri"/>
               </a:rPr>
-              <a:t>•  Risk scoring + adaptive MFA/block workflow</a:t>
+              <a:t>•  Stolen-credential logins at odd hours</a:t>
             </a:r>
           </a:p>
           <a:p>
@@ -11861,7 +12313,7 @@
                 </a:solidFill>
                 <a:latin typeface="Calibri"/>
               </a:rPr>
-              <a:t>•  Security alert lifecycle &amp; notifications</a:t>
+              <a:t>•  Silent privilege abuse by authorized staff</a:t>
             </a:r>
           </a:p>
           <a:p>
@@ -11880,7 +12332,7 @@
                 </a:solidFill>
                 <a:latin typeface="Calibri"/>
               </a:rPr>
-              <a:t>•  AI analyst: LLM-generated incident summaries</a:t>
+              <a:t>•  Mass data exfiltration before anyone notices</a:t>
             </a:r>
           </a:p>
         </p:txBody>
@@ -11937,7 +12389,7 @@
                 </a:solidFill>
                 <a:latin typeface="Calibri"/>
               </a:rPr>
-              <a:t>Stretch Goals</a:t>
+              <a:t>Beyond This Submission</a:t>
             </a:r>
           </a:p>
         </p:txBody>
@@ -12082,7 +12534,7 @@
                 </a:solidFill>
                 <a:latin typeface="Calibri"/>
               </a:rPr>
-              <a:t>•  React dashboard + Docker full deployment</a:t>
+              <a:t>•  SOC/SIEM integration (Splunk, ELK)</a:t>
             </a:r>
           </a:p>
         </p:txBody>
@@ -12121,7 +12573,7 @@
                 </a:solidFill>
                 <a:latin typeface="Calibri"/>
               </a:rPr>
-              <a:t>Guiding principle going forward: keep authorization deterministic and auditable — ML and AI only ever inform the strength of the response, never replace the policy decision.</a:t>
+              <a:t>Guiding principle throughout: keep authorization deterministic and auditable — ML and AI only ever inform the strength of the response, never replace the policy decision.</a:t>
             </a:r>
           </a:p>
         </p:txBody>
@@ -12550,6 +13002,25 @@
               <a:t>•  Database security → PostgreSQL schema &amp; access control</a:t>
             </a:r>
           </a:p>
+          <a:p>
+            <a:pPr>
+              <a:lnSpc>
+                <a:spcPct val="108000"/>
+              </a:lnSpc>
+              <a:spcAft>
+                <a:spcPts val="800"/>
+              </a:spcAft>
+            </a:pPr>
+            <a:r>
+              <a:rPr sz="1300" b="0">
+                <a:solidFill>
+                  <a:srgbClr val="00B4D8"/>
+                </a:solidFill>
+                <a:latin typeface="Calibri"/>
+              </a:rPr>
+              <a:t>•  Applied ML → Isolation Forest, precision/recall/F1 evaluated</a:t>
+            </a:r>
+          </a:p>
         </p:txBody>
       </p:sp>
       <p:sp>
@@ -16724,7 +17195,7 @@
                 </a:solidFill>
                 <a:latin typeface="Calibri"/>
               </a:rPr>
-              <a:t>Target scope: “Resume-Ready Version”</a:t>
+              <a:t>Delivered: the full “Resume-Ready Version”</a:t>
             </a:r>
           </a:p>
           <a:p>
@@ -16735,7 +17206,7 @@
                 </a:solidFill>
                 <a:latin typeface="Calibri"/>
               </a:rPr>
-              <a:t>→ Hybrid access control + audit logging</a:t>
+              <a:t>✓ Hybrid access control (RBAC+MAC+ABAC+TBAC+OBAC) + audit logging</a:t>
             </a:r>
           </a:p>
           <a:p>
@@ -16746,7 +17217,7 @@
                 </a:solidFill>
                 <a:latin typeface="Calibri"/>
               </a:rPr>
-              <a:t>→ + ML anomaly detection + risk scoring</a:t>
+              <a:t>✓ ML anomaly detection (Isolation Forest) + blended risk scoring</a:t>
             </a:r>
           </a:p>
           <a:p>
@@ -16757,7 +17228,7 @@
                 </a:solidFill>
                 <a:latin typeface="Calibri"/>
               </a:rPr>
-              <a:t>→ + adaptive responses + admin dashboard</a:t>
+              <a:t>✓ Adaptive responses (MFA / email / lockout) + React admin dashboard</a:t>
             </a:r>
           </a:p>
           <a:p>
@@ -16768,7 +17239,7 @@
                 </a:solidFill>
                 <a:latin typeface="Calibri"/>
               </a:rPr>
-              <a:t>→ + AI incident explanations + Docker deployment</a:t>
+              <a:t>✓ AI incident explanations + full Docker deployment</a:t>
             </a:r>
           </a:p>
         </p:txBody>
@@ -17910,7 +18381,7 @@
                 </a:solidFill>
                 <a:latin typeface="Calibri"/>
               </a:rPr>
-              <a:t>ALLOW • MFA • BLOCK</a:t>
+              <a:t>ALLOW • MFA/EMAIL • BLOCK</a:t>
             </a:r>
           </a:p>
         </p:txBody>
@@ -17949,7 +18420,7 @@
                 </a:solidFill>
                 <a:latin typeface="Calibri"/>
               </a:rPr>
-              <a:t>Same valid credentials, but abnormal behavior escalates the response.</a:t>
+              <a:t>Same valid credentials, but abnormal behavior escalates the response — repeat offenders get locked out for admin review.</a:t>
             </a:r>
           </a:p>
         </p:txBody>
@@ -18180,7 +18651,7 @@
                 </a:solidFill>
                 <a:latin typeface="Calibri"/>
               </a:rPr>
-              <a:t>Hybrid Policy Engine: RBAC + MAC + ABAC + TBAC</a:t>
+              <a:t>Hybrid Policy Engine: RBAC + MAC + ABAC + TBAC + OBAC</a:t>
             </a:r>
           </a:p>
         </p:txBody>
@@ -19228,7 +19699,7 @@
                 </a:solidFill>
                 <a:latin typeface="Calibri"/>
               </a:rPr>
-              <a:t>A single failing dimension overrides all passing ones — e.g. an otherwise fully-authorized request outside business hours is still denied by TBAC.</a:t>
+              <a:t>A single failing dimension overrides all passing ones — e.g. an otherwise fully-authorized request outside business hours is still denied by TBAC. A 5th, opt-in layer (OBAC) adds per-action rules on top — e.g. only Admins can DELETE — without ever loosening the first four.</a:t>
             </a:r>
           </a:p>
         </p:txBody>
@@ -21544,7 +22015,7 @@
                 </a:solidFill>
                 <a:latin typeface="Calibri"/>
               </a:rPr>
-              <a:t>Require additional authentication</a:t>
+              <a:t>Require step-up: MFA, else emailed code</a:t>
             </a:r>
           </a:p>
         </p:txBody>

</xml_diff>